<commit_message>
Add unit tests for architecture diagrams, bedroom uncertainty, intervention evaluation, next day temperature comparison, published hybrid comparison, research openspec, and RNN public comparison
- Implement tests for rendering SVGs in architecture diagrams.
- Create tests for bedroom uncertainty analysis functions.
- Add comprehensive tests for intervention evaluation metrics and validation.
- Introduce tests for next day temperature comparison features and predictions.
- Develop tests for published hybrid comparison metrics and standardization.
- Validate research openspec structure and completion criteria.
- Ensure RNN public comparison maintains deterministic behavior and data integrity.
</commit_message>
<xml_diff>
--- a/docs/papers/thesis/thesis_presentation_zh.pptx
+++ b/docs/papers/thesis/thesis_presentation_zh.pptx
@@ -4761,17 +4761,17 @@
                 <a:spcPct val="112000"/>
               </a:lnSpc>
               <a:spcAft>
-                <a:spcPts val="630"/>
-              </a:spcAft>
-              <a:defRPr sz="1400">
-                <a:solidFill>
-                  <a:srgbClr val="1E2733"/>
-                </a:solidFill>
-                <a:latin typeface="Noto Sans TC"/>
-              </a:defRPr>
-            </a:pPr>
-            <a:r>
-              <a:rPr sz="1400" b="0">
+                <a:spcPts val="540"/>
+              </a:spcAft>
+              <a:defRPr sz="1200">
+                <a:solidFill>
+                  <a:srgbClr val="1E2733"/>
+                </a:solidFill>
+                <a:latin typeface="Noto Sans TC"/>
+              </a:defRPr>
+            </a:pPr>
+            <a:r>
+              <a:rPr sz="1200" b="0">
                 <a:solidFill>
                   <a:srgbClr val="1E2733"/>
                 </a:solidFill>
@@ -4786,17 +4786,17 @@
                 <a:spcPct val="112000"/>
               </a:lnSpc>
               <a:spcAft>
-                <a:spcPts val="630"/>
-              </a:spcAft>
-              <a:defRPr sz="1400">
-                <a:solidFill>
-                  <a:srgbClr val="1E2733"/>
-                </a:solidFill>
-                <a:latin typeface="Noto Sans TC"/>
-              </a:defRPr>
-            </a:pPr>
-            <a:r>
-              <a:rPr sz="1400" b="0">
+                <a:spcPts val="540"/>
+              </a:spcAft>
+              <a:defRPr sz="1200">
+                <a:solidFill>
+                  <a:srgbClr val="1E2733"/>
+                </a:solidFill>
+                <a:latin typeface="Noto Sans TC"/>
+              </a:defRPr>
+            </a:pPr>
+            <a:r>
+              <a:rPr sz="1200" b="0">
                 <a:solidFill>
                   <a:srgbClr val="1E2733"/>
                 </a:solidFill>
@@ -4811,23 +4811,48 @@
                 <a:spcPct val="112000"/>
               </a:lnSpc>
               <a:spcAft>
-                <a:spcPts val="630"/>
-              </a:spcAft>
-              <a:defRPr sz="1400">
-                <a:solidFill>
-                  <a:srgbClr val="1E2733"/>
-                </a:solidFill>
-                <a:latin typeface="Noto Sans TC"/>
-              </a:defRPr>
-            </a:pPr>
-            <a:r>
-              <a:rPr sz="1400" b="0">
-                <a:solidFill>
-                  <a:srgbClr val="1E2733"/>
-                </a:solidFill>
-                <a:latin typeface="Noto Sans TC"/>
-              </a:rPr>
-              <a:t>• 另以 bedroom_01 真實快照檢查 sparse calibration 對 pillow 點的改善</a:t>
+                <a:spcPts val="540"/>
+              </a:spcAft>
+              <a:defRPr sz="1200">
+                <a:solidFill>
+                  <a:srgbClr val="1E2733"/>
+                </a:solidFill>
+                <a:latin typeface="Noto Sans TC"/>
+              </a:defRPr>
+            </a:pPr>
+            <a:r>
+              <a:rPr sz="1200" b="0">
+                <a:solidFill>
+                  <a:srgbClr val="1E2733"/>
+                </a:solidFill>
+                <a:latin typeface="Noto Sans TC"/>
+              </a:rPr>
+              <a:t>• E7 以 20,000 次 date-block bootstrap 檢查 pillow 改善，三因子 95% CI 下界皆 &gt; 0</a:t>
+            </a:r>
+          </a:p>
+          <a:p>
+            <a:pPr>
+              <a:lnSpc>
+                <a:spcPct val="112000"/>
+              </a:lnSpc>
+              <a:spcAft>
+                <a:spcPts val="540"/>
+              </a:spcAft>
+              <a:defRPr sz="1200">
+                <a:solidFill>
+                  <a:srgbClr val="1E2733"/>
+                </a:solidFill>
+                <a:latin typeface="Noto Sans TC"/>
+              </a:defRPr>
+            </a:pPr>
+            <a:r>
+              <a:rPr sz="1200" b="0">
+                <a:solidFill>
+                  <a:srgbClr val="1E2733"/>
+                </a:solidFill>
+                <a:latin typeface="Noto Sans TC"/>
+              </a:rPr>
+              <a:t>• E7 逐日剔除最小降幅：T 0.6123 / H 3.5551 / L 290.5716</a:t>
             </a:r>
           </a:p>
         </p:txBody>
@@ -5074,7 +5099,7 @@
         <p:spPr>
           <a:xfrm>
             <a:off x="822960" y="4617720"/>
-            <a:ext cx="10607040" cy="1325880"/>
+            <a:ext cx="10607040" cy="1463040"/>
           </a:xfrm>
           <a:prstGeom prst="rect">
             <a:avLst/>
@@ -5092,17 +5117,17 @@
                 <a:spcPct val="112000"/>
               </a:lnSpc>
               <a:spcAft>
-                <a:spcPts val="630"/>
-              </a:spcAft>
-              <a:defRPr sz="1400">
-                <a:solidFill>
-                  <a:srgbClr val="1E2733"/>
-                </a:solidFill>
-                <a:latin typeface="Noto Sans TC"/>
-              </a:defRPr>
-            </a:pPr>
-            <a:r>
-              <a:rPr sz="1400" b="0">
+                <a:spcPts val="540"/>
+              </a:spcAft>
+              <a:defRPr sz="1200">
+                <a:solidFill>
+                  <a:srgbClr val="1E2733"/>
+                </a:solidFill>
+                <a:latin typeface="Noto Sans TC"/>
+              </a:defRPr>
+            </a:pPr>
+            <a:r>
+              <a:rPr sz="1200" b="0">
                 <a:solidFill>
                   <a:srgbClr val="1E2733"/>
                 </a:solidFill>
@@ -5117,17 +5142,17 @@
                 <a:spcPct val="112000"/>
               </a:lnSpc>
               <a:spcAft>
-                <a:spcPts val="630"/>
-              </a:spcAft>
-              <a:defRPr sz="1400">
-                <a:solidFill>
-                  <a:srgbClr val="1E2733"/>
-                </a:solidFill>
-                <a:latin typeface="Noto Sans TC"/>
-              </a:defRPr>
-            </a:pPr>
-            <a:r>
-              <a:rPr sz="1400" b="0">
+                <a:spcPts val="540"/>
+              </a:spcAft>
+              <a:defRPr sz="1200">
+                <a:solidFill>
+                  <a:srgbClr val="1E2733"/>
+                </a:solidFill>
+                <a:latin typeface="Noto Sans TC"/>
+              </a:defRPr>
+            </a:pPr>
+            <a:r>
+              <a:rPr sz="1200" b="0">
                 <a:solidFill>
                   <a:srgbClr val="1E2733"/>
                 </a:solidFill>
@@ -5142,23 +5167,123 @@
                 <a:spcPct val="112000"/>
               </a:lnSpc>
               <a:spcAft>
-                <a:spcPts val="630"/>
-              </a:spcAft>
-              <a:defRPr sz="1400">
-                <a:solidFill>
-                  <a:srgbClr val="1E2733"/>
-                </a:solidFill>
-                <a:latin typeface="Noto Sans TC"/>
-              </a:defRPr>
-            </a:pPr>
-            <a:r>
-              <a:rPr sz="1400" b="0">
-                <a:solidFill>
-                  <a:srgbClr val="1E2733"/>
-                </a:solidFill>
-                <a:latin typeface="Noto Sans TC"/>
-              </a:rPr>
-              <a:t>• CU-BEMS C1/C3 可勝過 linear regression，但商辦 zone-level persistence 太強，不能宣稱全面勝出</a:t>
+                <a:spcPts val="540"/>
+              </a:spcAft>
+              <a:defRPr sz="1200">
+                <a:solidFill>
+                  <a:srgbClr val="1E2733"/>
+                </a:solidFill>
+                <a:latin typeface="Noto Sans TC"/>
+              </a:defRPr>
+            </a:pPr>
+            <a:r>
+              <a:rPr sz="1200" b="0">
+                <a:solidFill>
+                  <a:srgbClr val="1E2733"/>
+                </a:solidFill>
+                <a:latin typeface="Noto Sans TC"/>
+              </a:rPr>
+              <a:t>• Oh2024-inspired residual：15min 兩點溫度最佳；60min 本研究 readout 最佳；24h persistence 最佳</a:t>
+            </a:r>
+          </a:p>
+          <a:p>
+            <a:pPr>
+              <a:lnSpc>
+                <a:spcPct val="112000"/>
+              </a:lnSpc>
+              <a:spcAft>
+                <a:spcPts val="540"/>
+              </a:spcAft>
+              <a:defRPr sz="1200">
+                <a:solidFill>
+                  <a:srgbClr val="1E2733"/>
+                </a:solidFill>
+                <a:latin typeface="Noto Sans TC"/>
+              </a:defRPr>
+            </a:pPr>
+            <a:r>
+              <a:rPr sz="1200" b="0">
+                <a:solidFill>
+                  <a:srgbClr val="1E2733"/>
+                </a:solidFill>
+                <a:latin typeface="Noto Sans TC"/>
+              </a:rPr>
+              <a:t>• 次日 primary：validation 選出的 daily trend 反而惡化 7.34% / 8.36%；bootstrap interval 均跨 0</a:t>
+            </a:r>
+          </a:p>
+          <a:p>
+            <a:pPr>
+              <a:lnSpc>
+                <a:spcPct val="112000"/>
+              </a:lnSpc>
+              <a:spcAft>
+                <a:spcPts val="540"/>
+              </a:spcAft>
+              <a:defRPr sz="1200">
+                <a:solidFill>
+                  <a:srgbClr val="1E2733"/>
+                </a:solidFill>
+                <a:latin typeface="Noto Sans TC"/>
+              </a:defRPr>
+            </a:pPr>
+            <a:r>
+              <a:rPr sz="1200" b="0">
+                <a:solidFill>
+                  <a:srgbClr val="1E2733"/>
+                </a:solidFill>
+                <a:latin typeface="Noto Sans TC"/>
+              </a:rPr>
+              <a:t>• 探索性 adaptive median 亦惡化 8.83% / 9.73%；約 1% 的未選中 bias correction 不足以主張優勢</a:t>
+            </a:r>
+          </a:p>
+          <a:p>
+            <a:pPr>
+              <a:lnSpc>
+                <a:spcPct val="112000"/>
+              </a:lnSpc>
+              <a:spcAft>
+                <a:spcPts val="540"/>
+              </a:spcAft>
+              <a:defRPr sz="1200">
+                <a:solidFill>
+                  <a:srgbClr val="1E2733"/>
+                </a:solidFill>
+                <a:latin typeface="Noto Sans TC"/>
+              </a:defRPr>
+            </a:pPr>
+            <a:r>
+              <a:rPr sz="1200" b="0">
+                <a:solidFill>
+                  <a:srgbClr val="1E2733"/>
+                </a:solidFill>
+                <a:latin typeface="Noto Sans TC"/>
+              </a:rPr>
+              <a:t>• RNN 同資料比較：12/12 通過 parity；lowest MAE = sequence LR 7、persistence 5、RNN 0</a:t>
+            </a:r>
+          </a:p>
+          <a:p>
+            <a:pPr>
+              <a:lnSpc>
+                <a:spcPct val="112000"/>
+              </a:lnSpc>
+              <a:spcAft>
+                <a:spcPts val="540"/>
+              </a:spcAft>
+              <a:defRPr sz="1200">
+                <a:solidFill>
+                  <a:srgbClr val="1E2733"/>
+                </a:solidFill>
+                <a:latin typeface="Noto Sans TC"/>
+              </a:defRPr>
+            </a:pPr>
+            <a:r>
+              <a:rPr sz="1200" b="0">
+                <a:solidFill>
+                  <a:srgbClr val="1E2733"/>
+                </a:solidFill>
+                <a:latin typeface="Noto Sans TC"/>
+              </a:rPr>
+              <a:t>• 四種方法共用四筆 history、split、targets 與 test rows；負向結果保留</a:t>
             </a:r>
           </a:p>
         </p:txBody>
@@ -5375,17 +5500,17 @@
                 <a:spcPct val="112000"/>
               </a:lnSpc>
               <a:spcAft>
-                <a:spcPts val="810"/>
-              </a:spcAft>
-              <a:defRPr sz="1800">
-                <a:solidFill>
-                  <a:srgbClr val="1E2733"/>
-                </a:solidFill>
-                <a:latin typeface="Noto Sans TC"/>
-              </a:defRPr>
-            </a:pPr>
-            <a:r>
-              <a:rPr sz="1800" b="0">
+                <a:spcPts val="720"/>
+              </a:spcAft>
+              <a:defRPr sz="1600">
+                <a:solidFill>
+                  <a:srgbClr val="1E2733"/>
+                </a:solidFill>
+                <a:latin typeface="Noto Sans TC"/>
+              </a:defRPr>
+            </a:pPr>
+            <a:r>
+              <a:rPr sz="1600" b="0">
                 <a:solidFill>
                   <a:srgbClr val="1E2733"/>
                 </a:solidFill>
@@ -5400,17 +5525,17 @@
                 <a:spcPct val="112000"/>
               </a:lnSpc>
               <a:spcAft>
-                <a:spcPts val="810"/>
-              </a:spcAft>
-              <a:defRPr sz="1800">
-                <a:solidFill>
-                  <a:srgbClr val="1E2733"/>
-                </a:solidFill>
-                <a:latin typeface="Noto Sans TC"/>
-              </a:defRPr>
-            </a:pPr>
-            <a:r>
-              <a:rPr sz="1800" b="0">
+                <a:spcPts val="720"/>
+              </a:spcAft>
+              <a:defRPr sz="1600">
+                <a:solidFill>
+                  <a:srgbClr val="1E2733"/>
+                </a:solidFill>
+                <a:latin typeface="Noto Sans TC"/>
+              </a:defRPr>
+            </a:pPr>
+            <a:r>
+              <a:rPr sz="1600" b="0">
                 <a:solidFill>
                   <a:srgbClr val="1E2733"/>
                 </a:solidFill>
@@ -5425,17 +5550,17 @@
                 <a:spcPct val="112000"/>
               </a:lnSpc>
               <a:spcAft>
-                <a:spcPts val="810"/>
-              </a:spcAft>
-              <a:defRPr sz="1800">
-                <a:solidFill>
-                  <a:srgbClr val="1E2733"/>
-                </a:solidFill>
-                <a:latin typeface="Noto Sans TC"/>
-              </a:defRPr>
-            </a:pPr>
-            <a:r>
-              <a:rPr sz="1800" b="0">
+                <a:spcPts val="720"/>
+              </a:spcAft>
+              <a:defRPr sz="1600">
+                <a:solidFill>
+                  <a:srgbClr val="1E2733"/>
+                </a:solidFill>
+                <a:latin typeface="Noto Sans TC"/>
+              </a:defRPr>
+            </a:pPr>
+            <a:r>
+              <a:rPr sz="1600" b="0">
                 <a:solidFill>
                   <a:srgbClr val="1E2733"/>
                 </a:solidFill>
@@ -5450,17 +5575,17 @@
                 <a:spcPct val="112000"/>
               </a:lnSpc>
               <a:spcAft>
-                <a:spcPts val="810"/>
-              </a:spcAft>
-              <a:defRPr sz="1800">
-                <a:solidFill>
-                  <a:srgbClr val="1E2733"/>
-                </a:solidFill>
-                <a:latin typeface="Noto Sans TC"/>
-              </a:defRPr>
-            </a:pPr>
-            <a:r>
-              <a:rPr sz="1800" b="0">
+                <a:spcPts val="720"/>
+              </a:spcAft>
+              <a:defRPr sz="1600">
+                <a:solidFill>
+                  <a:srgbClr val="1E2733"/>
+                </a:solidFill>
+                <a:latin typeface="Noto Sans TC"/>
+              </a:defRPr>
+            </a:pPr>
+            <a:r>
+              <a:rPr sz="1600" b="0">
                 <a:solidFill>
                   <a:srgbClr val="1E2733"/>
                 </a:solidFill>
@@ -5475,17 +5600,17 @@
                 <a:spcPct val="112000"/>
               </a:lnSpc>
               <a:spcAft>
-                <a:spcPts val="810"/>
-              </a:spcAft>
-              <a:defRPr sz="1800">
-                <a:solidFill>
-                  <a:srgbClr val="1E2733"/>
-                </a:solidFill>
-                <a:latin typeface="Noto Sans TC"/>
-              </a:defRPr>
-            </a:pPr>
-            <a:r>
-              <a:rPr sz="1800" b="0">
+                <a:spcPts val="720"/>
+              </a:spcAft>
+              <a:defRPr sz="1600">
+                <a:solidFill>
+                  <a:srgbClr val="1E2733"/>
+                </a:solidFill>
+                <a:latin typeface="Noto Sans TC"/>
+              </a:defRPr>
+            </a:pPr>
+            <a:r>
+              <a:rPr sz="1600" b="0">
                 <a:solidFill>
                   <a:srgbClr val="1E2733"/>
                 </a:solidFill>
@@ -5500,17 +5625,17 @@
                 <a:spcPct val="112000"/>
               </a:lnSpc>
               <a:spcAft>
-                <a:spcPts val="810"/>
-              </a:spcAft>
-              <a:defRPr sz="1800">
-                <a:solidFill>
-                  <a:srgbClr val="1E2733"/>
-                </a:solidFill>
-                <a:latin typeface="Noto Sans TC"/>
-              </a:defRPr>
-            </a:pPr>
-            <a:r>
-              <a:rPr sz="1800" b="0">
+                <a:spcPts val="720"/>
+              </a:spcAft>
+              <a:defRPr sz="1600">
+                <a:solidFill>
+                  <a:srgbClr val="1E2733"/>
+                </a:solidFill>
+                <a:latin typeface="Noto Sans TC"/>
+              </a:defRPr>
+            </a:pPr>
+            <a:r>
+              <a:rPr sz="1600" b="0">
                 <a:solidFill>
                   <a:srgbClr val="1E2733"/>
                 </a:solidFill>
@@ -5525,23 +5650,48 @@
                 <a:spcPct val="112000"/>
               </a:lnSpc>
               <a:spcAft>
-                <a:spcPts val="810"/>
-              </a:spcAft>
-              <a:defRPr sz="1800">
-                <a:solidFill>
-                  <a:srgbClr val="1E2733"/>
-                </a:solidFill>
-                <a:latin typeface="Noto Sans TC"/>
-              </a:defRPr>
-            </a:pPr>
-            <a:r>
-              <a:rPr sz="1800" b="0">
+                <a:spcPts val="720"/>
+              </a:spcAft>
+              <a:defRPr sz="1600">
+                <a:solidFill>
+                  <a:srgbClr val="1E2733"/>
+                </a:solidFill>
+                <a:latin typeface="Noto Sans TC"/>
+              </a:defRPr>
+            </a:pPr>
+            <a:r>
+              <a:rPr sz="1600" b="0">
                 <a:solidFill>
                   <a:srgbClr val="1E2733"/>
                 </a:solidFill>
                 <a:latin typeface="Noto Sans TC"/>
               </a:rPr>
               <a:t>• 公開資料集則採 task-aligned benchmark：CU-BEMS / SML2010 / ASHRAE 各比相容子任務</a:t>
+            </a:r>
+          </a:p>
+          <a:p>
+            <a:pPr>
+              <a:lnSpc>
+                <a:spcPct val="112000"/>
+              </a:lnSpc>
+              <a:spcAft>
+                <a:spcPts val="720"/>
+              </a:spcAft>
+              <a:defRPr sz="1600">
+                <a:solidFill>
+                  <a:srgbClr val="1E2733"/>
+                </a:solidFill>
+                <a:latin typeface="Noto Sans TC"/>
+              </a:defRPr>
+            </a:pPr>
+            <a:r>
+              <a:rPr sz="1600" b="0">
+                <a:solidFill>
+                  <a:srgbClr val="1E2733"/>
+                </a:solidFill>
+                <a:latin typeface="Noto Sans TC"/>
+              </a:rPr>
+              <a:t>• 室內應用溫度範圍固定 20–30 °C；人體舒適採目標帶與容許範圍</a:t>
             </a:r>
           </a:p>
         </p:txBody>
@@ -6262,15 +6412,15 @@
               <a:spcAft>
                 <a:spcPts val="400"/>
               </a:spcAft>
-              <a:defRPr sz="1200">
-                <a:solidFill>
-                  <a:srgbClr val="1E2733"/>
-                </a:solidFill>
-                <a:latin typeface="Noto Sans TC"/>
-              </a:defRPr>
-            </a:pPr>
-            <a:r>
-              <a:rPr sz="1200" b="0">
+              <a:defRPr sz="1100">
+                <a:solidFill>
+                  <a:srgbClr val="1E2733"/>
+                </a:solidFill>
+                <a:latin typeface="Noto Sans TC"/>
+              </a:defRPr>
+            </a:pPr>
+            <a:r>
+              <a:rPr sz="1100" b="0">
                 <a:solidFill>
                   <a:srgbClr val="1E2733"/>
                 </a:solidFill>
@@ -6287,15 +6437,15 @@
               <a:spcAft>
                 <a:spcPts val="400"/>
               </a:spcAft>
-              <a:defRPr sz="1200">
-                <a:solidFill>
-                  <a:srgbClr val="1E2733"/>
-                </a:solidFill>
-                <a:latin typeface="Noto Sans TC"/>
-              </a:defRPr>
-            </a:pPr>
-            <a:r>
-              <a:rPr sz="1200" b="0">
+              <a:defRPr sz="1100">
+                <a:solidFill>
+                  <a:srgbClr val="1E2733"/>
+                </a:solidFill>
+                <a:latin typeface="Noto Sans TC"/>
+              </a:defRPr>
+            </a:pPr>
+            <a:r>
+              <a:rPr sz="1100" b="0">
                 <a:solidFill>
                   <a:srgbClr val="1E2733"/>
                 </a:solidFill>
@@ -6312,15 +6462,15 @@
               <a:spcAft>
                 <a:spcPts val="400"/>
               </a:spcAft>
-              <a:defRPr sz="1200">
-                <a:solidFill>
-                  <a:srgbClr val="1E2733"/>
-                </a:solidFill>
-                <a:latin typeface="Noto Sans TC"/>
-              </a:defRPr>
-            </a:pPr>
-            <a:r>
-              <a:rPr sz="1200" b="0">
+              <a:defRPr sz="1100">
+                <a:solidFill>
+                  <a:srgbClr val="1E2733"/>
+                </a:solidFill>
+                <a:latin typeface="Noto Sans TC"/>
+              </a:defRPr>
+            </a:pPr>
+            <a:r>
+              <a:rPr sz="1100" b="0">
                 <a:solidFill>
                   <a:srgbClr val="1E2733"/>
                 </a:solidFill>
@@ -6337,15 +6487,15 @@
               <a:spcAft>
                 <a:spcPts val="400"/>
               </a:spcAft>
-              <a:defRPr sz="1200">
-                <a:solidFill>
-                  <a:srgbClr val="1E2733"/>
-                </a:solidFill>
-                <a:latin typeface="Noto Sans TC"/>
-              </a:defRPr>
-            </a:pPr>
-            <a:r>
-              <a:rPr sz="1200" b="0">
+              <a:defRPr sz="1100">
+                <a:solidFill>
+                  <a:srgbClr val="1E2733"/>
+                </a:solidFill>
+                <a:latin typeface="Noto Sans TC"/>
+              </a:defRPr>
+            </a:pPr>
+            <a:r>
+              <a:rPr sz="1100" b="0">
                 <a:solidFill>
                   <a:srgbClr val="1E2733"/>
                 </a:solidFill>
@@ -6362,15 +6512,15 @@
               <a:spcAft>
                 <a:spcPts val="400"/>
               </a:spcAft>
-              <a:defRPr sz="1200">
-                <a:solidFill>
-                  <a:srgbClr val="1E2733"/>
-                </a:solidFill>
-                <a:latin typeface="Noto Sans TC"/>
-              </a:defRPr>
-            </a:pPr>
-            <a:r>
-              <a:rPr sz="1200" b="0">
+              <a:defRPr sz="1100">
+                <a:solidFill>
+                  <a:srgbClr val="1E2733"/>
+                </a:solidFill>
+                <a:latin typeface="Noto Sans TC"/>
+              </a:defRPr>
+            </a:pPr>
+            <a:r>
+              <a:rPr sz="1100" b="0">
                 <a:solidFill>
                   <a:srgbClr val="1E2733"/>
                 </a:solidFill>
@@ -6387,21 +6537,46 @@
               <a:spcAft>
                 <a:spcPts val="400"/>
               </a:spcAft>
-              <a:defRPr sz="1200">
-                <a:solidFill>
-                  <a:srgbClr val="1E2733"/>
-                </a:solidFill>
-                <a:latin typeface="Noto Sans TC"/>
-              </a:defRPr>
-            </a:pPr>
-            <a:r>
-              <a:rPr sz="1200" b="0">
-                <a:solidFill>
-                  <a:srgbClr val="1E2733"/>
-                </a:solidFill>
-                <a:latin typeface="Noto Sans TC"/>
-              </a:rPr>
-              <a:t>• 研究遠端 MCP 與閉環控制</a:t>
+              <a:defRPr sz="1100">
+                <a:solidFill>
+                  <a:srgbClr val="1E2733"/>
+                </a:solidFill>
+                <a:latin typeface="Noto Sans TC"/>
+              </a:defRPr>
+            </a:pPr>
+            <a:r>
+              <a:rPr sz="1100" b="0">
+                <a:solidFill>
+                  <a:srgbClr val="1E2733"/>
+                </a:solidFill>
+                <a:latin typeface="Noto Sans TC"/>
+              </a:rPr>
+              <a:t>• 20–30 °C 動態植物生長環境：先補 PPFD/CO2/基質與生物 endpoint</a:t>
+            </a:r>
+          </a:p>
+          <a:p>
+            <a:pPr>
+              <a:lnSpc>
+                <a:spcPct val="114000"/>
+              </a:lnSpc>
+              <a:spcAft>
+                <a:spcPts val="400"/>
+              </a:spcAft>
+              <a:defRPr sz="1100">
+                <a:solidFill>
+                  <a:srgbClr val="1E2733"/>
+                </a:solidFill>
+                <a:latin typeface="Noto Sans TC"/>
+              </a:defRPr>
+            </a:pPr>
+            <a:r>
+              <a:rPr sz="1100" b="0">
+                <a:solidFill>
+                  <a:srgbClr val="1E2733"/>
+                </a:solidFill>
+                <a:latin typeface="Noto Sans TC"/>
+              </a:rPr>
+              <a:t>• 定義 state/observation/noise 後比較 moving average、KF 與 EKF</a:t>
             </a:r>
           </a:p>
         </p:txBody>
@@ -23310,14 +23485,14 @@
                 </a:solidFill>
                 <a:latin typeface="Noto Sans TC"/>
               </a:rPr>
-              <a:t>系統架構</a:t>
+              <a:t>論文整體邏輯：問題、方法、證據與結論邊界</a:t>
             </a:r>
           </a:p>
         </p:txBody>
       </p:sp>
       <p:pic>
         <p:nvPicPr>
-          <p:cNvPr id="5" name="Picture 4" descr="整體分層架構.png"/>
+          <p:cNvPr id="5" name="Picture 4" descr="研究整體邏輯架構.png"/>
           <p:cNvPicPr>
             <a:picLocks noChangeAspect="1"/>
           </p:cNvPicPr>
@@ -23331,8 +23506,8 @@
         </p:blipFill>
         <p:spPr>
           <a:xfrm>
-            <a:off x="731520" y="2121601"/>
-            <a:ext cx="5486400" cy="3071997"/>
+            <a:off x="1321317" y="1143000"/>
+            <a:ext cx="9564604" cy="5257800"/>
           </a:xfrm>
           <a:prstGeom prst="rect">
             <a:avLst/>
@@ -23341,130 +23516,7 @@
       </p:pic>
       <p:sp>
         <p:nvSpPr>
-          <p:cNvPr id="6" name="TextBox 5"/>
-          <p:cNvSpPr txBox="1"/>
-          <p:nvPr/>
-        </p:nvSpPr>
-        <p:spPr>
-          <a:xfrm>
-            <a:off x="6492240" y="1463040"/>
-            <a:ext cx="4754880" cy="4572000"/>
-          </a:xfrm>
-          <a:prstGeom prst="rect">
-            <a:avLst/>
-          </a:prstGeom>
-          <a:noFill/>
-        </p:spPr>
-        <p:txBody>
-          <a:bodyPr wrap="square" lIns="18288" rIns="18288" tIns="18288" bIns="18288">
-            <a:normAutofit/>
-          </a:bodyPr>
-          <a:lstStyle/>
-          <a:p>
-            <a:pPr>
-              <a:lnSpc>
-                <a:spcPct val="112000"/>
-              </a:lnSpc>
-              <a:spcAft>
-                <a:spcPts val="720"/>
-              </a:spcAft>
-              <a:defRPr sz="1600">
-                <a:solidFill>
-                  <a:srgbClr val="1E2733"/>
-                </a:solidFill>
-                <a:latin typeface="Noto Sans TC"/>
-              </a:defRPr>
-            </a:pPr>
-            <a:r>
-              <a:rPr sz="1600" b="0">
-                <a:solidFill>
-                  <a:srgbClr val="1E2733"/>
-                </a:solidFill>
-                <a:latin typeface="Noto Sans TC"/>
-              </a:rPr>
-              <a:t>• top-down tree 先區分三個責任域</a:t>
-            </a:r>
-          </a:p>
-          <a:p>
-            <a:pPr>
-              <a:lnSpc>
-                <a:spcPct val="112000"/>
-              </a:lnSpc>
-              <a:spcAft>
-                <a:spcPts val="720"/>
-              </a:spcAft>
-              <a:defRPr sz="1600">
-                <a:solidFill>
-                  <a:srgbClr val="1E2733"/>
-                </a:solidFill>
-                <a:latin typeface="Noto Sans TC"/>
-              </a:defRPr>
-            </a:pPr>
-            <a:r>
-              <a:rPr sz="1600" b="0">
-                <a:solidFill>
-                  <a:srgbClr val="1E2733"/>
-                </a:solidFill>
-                <a:latin typeface="Noto Sans TC"/>
-              </a:rPr>
-              <a:t>• 情境與觀測層整理房間、8 點感測與外部邊界</a:t>
-            </a:r>
-          </a:p>
-          <a:p>
-            <a:pPr>
-              <a:lnSpc>
-                <a:spcPct val="112000"/>
-              </a:lnSpc>
-              <a:spcAft>
-                <a:spcPts val="720"/>
-              </a:spcAft>
-              <a:defRPr sz="1600">
-                <a:solidFill>
-                  <a:srgbClr val="1E2733"/>
-                </a:solidFill>
-                <a:latin typeface="Noto Sans TC"/>
-              </a:defRPr>
-            </a:pPr>
-            <a:r>
-              <a:rPr sz="1600" b="0">
-                <a:solidFill>
-                  <a:srgbClr val="1E2733"/>
-                </a:solidFill>
-                <a:latin typeface="Noto Sans TC"/>
-              </a:rPr>
-              <a:t>• 估測與學習層負責 T/H/L field model、校正與 residual</a:t>
-            </a:r>
-          </a:p>
-          <a:p>
-            <a:pPr>
-              <a:lnSpc>
-                <a:spcPct val="112000"/>
-              </a:lnSpc>
-              <a:spcAft>
-                <a:spcPts val="720"/>
-              </a:spcAft>
-              <a:defRPr sz="1600">
-                <a:solidFill>
-                  <a:srgbClr val="1E2733"/>
-                </a:solidFill>
-                <a:latin typeface="Noto Sans TC"/>
-              </a:defRPr>
-            </a:pPr>
-            <a:r>
-              <a:rPr sz="1600" b="0">
-                <a:solidFill>
-                  <a:srgbClr val="1E2733"/>
-                </a:solidFill>
-                <a:latin typeface="Noto Sans TC"/>
-              </a:rPr>
-              <a:t>• 服務與決策層才包含 scripts、Web、MCP/Gemma 與 action ranking</a:t>
-            </a:r>
-          </a:p>
-        </p:txBody>
-      </p:sp>
-      <p:sp>
-        <p:nvSpPr>
-          <p:cNvPr id="7" name="footer_page_number"/>
+          <p:cNvPr id="6" name="footer_page_number"/>
           <p:cNvSpPr txBox="1"/>
           <p:nvPr/>
         </p:nvSpPr>
@@ -31954,7 +32006,97 @@
                 </a:solidFill>
                 <a:latin typeface="Noto Sans TC"/>
               </a:rPr>
-              <a:t>• θᵥ：該變數 residual model 的參數</a:t>
+              <a:t>• 預測推廣：ŷ</a:t>
+            </a:r>
+            <a:r>
+              <a:rPr sz="800" baseline="-25000">
+                <a:solidFill>
+                  <a:srgbClr val="1E2733"/>
+                </a:solidFill>
+                <a:latin typeface="Noto Sans TC"/>
+              </a:rPr>
+              <a:t>hybrid</a:t>
+            </a:r>
+            <a:r>
+              <a:rPr sz="1200" b="0">
+                <a:solidFill>
+                  <a:srgbClr val="1E2733"/>
+                </a:solidFill>
+                <a:latin typeface="Noto Sans TC"/>
+              </a:rPr>
+              <a:t>(t+h|I</a:t>
+            </a:r>
+            <a:r>
+              <a:rPr sz="800" baseline="-25000">
+                <a:solidFill>
+                  <a:srgbClr val="1E2733"/>
+                </a:solidFill>
+                <a:latin typeface="Noto Sans TC"/>
+              </a:rPr>
+              <a:t>t</a:t>
+            </a:r>
+            <a:r>
+              <a:rPr sz="1200" b="0">
+                <a:solidFill>
+                  <a:srgbClr val="1E2733"/>
+                </a:solidFill>
+                <a:latin typeface="Noto Sans TC"/>
+              </a:rPr>
+              <a:t>)=ŷ</a:t>
+            </a:r>
+            <a:r>
+              <a:rPr sz="800" baseline="-25000">
+                <a:solidFill>
+                  <a:srgbClr val="1E2733"/>
+                </a:solidFill>
+                <a:latin typeface="Noto Sans TC"/>
+              </a:rPr>
+              <a:t>phys</a:t>
+            </a:r>
+            <a:r>
+              <a:rPr sz="1200" b="0">
+                <a:solidFill>
+                  <a:srgbClr val="1E2733"/>
+                </a:solidFill>
+                <a:latin typeface="Noto Sans TC"/>
+              </a:rPr>
+              <a:t>(t+h|I</a:t>
+            </a:r>
+            <a:r>
+              <a:rPr sz="800" baseline="-25000">
+                <a:solidFill>
+                  <a:srgbClr val="1E2733"/>
+                </a:solidFill>
+                <a:latin typeface="Noto Sans TC"/>
+              </a:rPr>
+              <a:t>t</a:t>
+            </a:r>
+            <a:r>
+              <a:rPr sz="1200" b="0">
+                <a:solidFill>
+                  <a:srgbClr val="1E2733"/>
+                </a:solidFill>
+                <a:latin typeface="Noto Sans TC"/>
+              </a:rPr>
+              <a:t>)+ê(t+h|I</a:t>
+            </a:r>
+            <a:r>
+              <a:rPr sz="800" baseline="-25000">
+                <a:solidFill>
+                  <a:srgbClr val="1E2733"/>
+                </a:solidFill>
+                <a:latin typeface="Noto Sans TC"/>
+              </a:rPr>
+              <a:t>t</a:t>
+            </a:r>
+            <a:r>
+              <a:rPr sz="1200" b="0">
+                <a:solidFill>
+                  <a:srgbClr val="1E2733"/>
+                </a:solidFill>
+                <a:latin typeface="Noto Sans TC"/>
+              </a:rPr>
+              <a:t>)</a:t>
             </a:r>
           </a:p>
           <a:p>
@@ -31979,7 +32121,7 @@
                 </a:solidFill>
                 <a:latin typeface="Noto Sans TC"/>
               </a:rPr>
-              <a:t>• 每個變數可有自己的 residual 修正器</a:t>
+              <a:t>• h 是 lead time；兩項對齊同一 target time</a:t>
             </a:r>
           </a:p>
         </p:txBody>
@@ -32229,7 +32371,7 @@
                 </a:solidFill>
                 <a:latin typeface="Noto Sans TC"/>
               </a:rPr>
-              <a:t>• 它只修正主模型剩下的系統性誤差</a:t>
+              <a:t>• physics 有 t+h：主模型須預測目標時刻 baseline</a:t>
             </a:r>
           </a:p>
           <a:p>
@@ -32254,7 +32396,25 @@
                 </a:solidFill>
                 <a:latin typeface="Noto Sans TC"/>
               </a:rPr>
-              <a:t>• 這樣可保留可解釋結構</a:t>
+              <a:t>• I</a:t>
+            </a:r>
+            <a:r>
+              <a:rPr sz="800" baseline="-25000">
+                <a:solidFill>
+                  <a:srgbClr val="1E2733"/>
+                </a:solidFill>
+                <a:latin typeface="Noto Sans TC"/>
+              </a:rPr>
+              <a:t>t</a:t>
+            </a:r>
+            <a:r>
+              <a:rPr sz="1200" b="0">
+                <a:solidFill>
+                  <a:srgbClr val="1E2733"/>
+                </a:solidFill>
+                <a:latin typeface="Noto Sans TC"/>
+              </a:rPr>
+              <a:t> 只含 t 時可得資訊；禁止未來觀測 leakage</a:t>
             </a:r>
           </a:p>
           <a:p>
@@ -32279,7 +32439,7 @@
                 </a:solidFill>
                 <a:latin typeface="Noto Sans TC"/>
               </a:rPr>
-              <a:t>• 也能用資料修正不易手刻的偏差</a:t>
+              <a:t>• 本研究目前為 current-state spatial estimate，即 h=0</a:t>
             </a:r>
           </a:p>
           <a:p>
@@ -39113,7 +39273,7 @@
                 </a:solidFill>
                 <a:latin typeface="Noto Sans TC"/>
               </a:rPr>
-              <a:t>• 窗戶矩陣 48 組</a:t>
+              <a:t>• 窗戶矩陣 48 組：34 範圍內／14 壓力測試</a:t>
             </a:r>
           </a:p>
           <a:p>
@@ -40605,7 +40765,7 @@
                 </a:solidFill>
                 <a:latin typeface="Noto Sans TC"/>
               </a:rPr>
-              <a:t>• E5：window matrix 48 組外部邊界條件</a:t>
+              <a:t>• E5：window matrix 48 組（34 範圍內／14 壓力測試）</a:t>
             </a:r>
           </a:p>
           <a:p>
@@ -40680,7 +40840,32 @@
                 </a:solidFill>
                 <a:latin typeface="Noto Sans TC"/>
               </a:rPr>
-              <a:t>• E8 protocol、E9 public benchmark；demo 不是量化實驗</a:t>
+              <a:t>• E8 execution kit：schema / template / analyzer；0 trials、NOT_EVALUATED</a:t>
+            </a:r>
+          </a:p>
+          <a:p>
+            <a:pPr>
+              <a:lnSpc>
+                <a:spcPct val="112000"/>
+              </a:lnSpc>
+              <a:spcAft>
+                <a:spcPts val="720"/>
+              </a:spcAft>
+              <a:defRPr sz="1600">
+                <a:solidFill>
+                  <a:srgbClr val="1E2733"/>
+                </a:solidFill>
+                <a:latin typeface="Noto Sans TC"/>
+              </a:defRPr>
+            </a:pPr>
+            <a:r>
+              <a:rPr sz="1600" b="0">
+                <a:solidFill>
+                  <a:srgbClr val="1E2733"/>
+                </a:solidFill>
+                <a:latin typeface="Noto Sans TC"/>
+              </a:rPr>
+              <a:t>• E9 public benchmark；demo 不是量化實驗</a:t>
             </a:r>
           </a:p>
         </p:txBody>

</xml_diff>

<commit_message>
feat: synchronize thesis experiments and enclosure evaluation
</commit_message>
<xml_diff>
--- a/docs/papers/thesis/thesis_presentation_zh.pptx
+++ b/docs/papers/thesis/thesis_presentation_zh.pptx
@@ -3434,8 +3434,8 @@
         </p:blipFill>
         <p:spPr>
           <a:xfrm>
-            <a:off x="6126480" y="2132561"/>
-            <a:ext cx="5120640" cy="2867197"/>
+            <a:off x="6492240" y="1371600"/>
+            <a:ext cx="4389120" cy="4389120"/>
           </a:xfrm>
           <a:prstGeom prst="rect">
             <a:avLst/>
@@ -4380,7 +4380,7 @@
                 </a:solidFill>
                 <a:latin typeface="Noto Sans TC"/>
               </a:rPr>
-              <a:t>Hybrid Residual Neural Network 結果</a:t>
+              <a:t>Pure RNN 與 Hybrid Residual 結果</a:t>
             </a:r>
           </a:p>
         </p:txBody>
@@ -4680,6 +4680,31 @@
                 </a:solidFill>
                 <a:latin typeface="Noto Sans TC"/>
               </a:rPr>
+              <a:t>• Pure RNN LOO MAE: T=0.2091, H=0.2241, L=48.1422</a:t>
+            </a:r>
+          </a:p>
+          <a:p>
+            <a:pPr>
+              <a:lnSpc>
+                <a:spcPct val="114000"/>
+              </a:lnSpc>
+              <a:spcAft>
+                <a:spcPts val="400"/>
+              </a:spcAft>
+              <a:defRPr sz="1100">
+                <a:solidFill>
+                  <a:srgbClr val="1E2733"/>
+                </a:solidFill>
+                <a:latin typeface="Noto Sans TC"/>
+              </a:defRPr>
+            </a:pPr>
+            <a:r>
+              <a:rPr sz="1100" b="0">
+                <a:solidFill>
+                  <a:srgbClr val="1E2733"/>
+                </a:solidFill>
+                <a:latin typeface="Noto Sans TC"/>
+              </a:rPr>
               <a:t>• LOO avg hybrid MAE: T=0.0017, H=0.0059, L=0.1407</a:t>
             </a:r>
           </a:p>
@@ -4778,6 +4803,31 @@
                 <a:latin typeface="Noto Sans TC"/>
               </a:rPr>
               <a:t>• hybrid residual 是第二層修正器，不取代主模型</a:t>
+            </a:r>
+          </a:p>
+          <a:p>
+            <a:pPr>
+              <a:lnSpc>
+                <a:spcPct val="112000"/>
+              </a:lnSpc>
+              <a:spcAft>
+                <a:spcPts val="540"/>
+              </a:spcAft>
+              <a:defRPr sz="1200">
+                <a:solidFill>
+                  <a:srgbClr val="1E2733"/>
+                </a:solidFill>
+                <a:latin typeface="Noto Sans TC"/>
+              </a:defRPr>
+            </a:pPr>
+            <a:r>
+              <a:rPr sz="1200" b="0">
+                <a:solidFill>
+                  <a:srgbClr val="1E2733"/>
+                </a:solidFill>
+                <a:latin typeface="Noto Sans TC"/>
+              </a:rPr>
+              <a:t>• Pure RNN 不使用 physics estimate；8/8 folds parity，lowest MAE 0/24</a:t>
             </a:r>
           </a:p>
           <a:p>
@@ -5258,7 +5308,7 @@
                 </a:solidFill>
                 <a:latin typeface="Noto Sans TC"/>
               </a:rPr>
-              <a:t>• RNN 同資料比較：12/12 通過 parity；lowest MAE = sequence LR 7、persistence 5、RNN 0</a:t>
+              <a:t>• SML2010 時序 RNN：12/12 通過 parity；lowest MAE = sequence LR 7、persistence 5、RNN 0</a:t>
             </a:r>
           </a:p>
           <a:p>
@@ -5284,6 +5334,31 @@
                 <a:latin typeface="Noto Sans TC"/>
               </a:rPr>
               <a:t>• 四種方法共用四筆 history、split、targets 與 test rows；負向結果保留</a:t>
+            </a:r>
+          </a:p>
+          <a:p>
+            <a:pPr>
+              <a:lnSpc>
+                <a:spcPct val="112000"/>
+              </a:lnSpc>
+              <a:spcAft>
+                <a:spcPts val="540"/>
+              </a:spcAft>
+              <a:defRPr sz="1200">
+                <a:solidFill>
+                  <a:srgbClr val="1E2733"/>
+                </a:solidFill>
+                <a:latin typeface="Noto Sans TC"/>
+              </a:defRPr>
+            </a:pPr>
+            <a:r>
+              <a:rPr sz="1200" b="0">
+                <a:solidFill>
+                  <a:srgbClr val="1E2733"/>
+                </a:solidFill>
+                <a:latin typeface="Noto Sans TC"/>
+              </a:rPr>
+              <a:t>• Kalman 受控 filtering：12/12 parity；lowest MAE = MA(3) 6、Linear Kalman 6、raw 0</a:t>
             </a:r>
           </a:p>
         </p:txBody>
@@ -6087,15 +6162,15 @@
               <a:spcAft>
                 <a:spcPts val="400"/>
               </a:spcAft>
-              <a:defRPr sz="1200">
-                <a:solidFill>
-                  <a:srgbClr val="1E2733"/>
-                </a:solidFill>
-                <a:latin typeface="Noto Sans TC"/>
-              </a:defRPr>
-            </a:pPr>
-            <a:r>
-              <a:rPr sz="1200" b="0">
+              <a:defRPr sz="1100">
+                <a:solidFill>
+                  <a:srgbClr val="1E2733"/>
+                </a:solidFill>
+                <a:latin typeface="Noto Sans TC"/>
+              </a:defRPr>
+            </a:pPr>
+            <a:r>
+              <a:rPr sz="1100" b="0">
                 <a:solidFill>
                   <a:srgbClr val="1E2733"/>
                 </a:solidFill>
@@ -6112,15 +6187,15 @@
               <a:spcAft>
                 <a:spcPts val="400"/>
               </a:spcAft>
-              <a:defRPr sz="1200">
-                <a:solidFill>
-                  <a:srgbClr val="1E2733"/>
-                </a:solidFill>
-                <a:latin typeface="Noto Sans TC"/>
-              </a:defRPr>
-            </a:pPr>
-            <a:r>
-              <a:rPr sz="1200" b="0">
+              <a:defRPr sz="1100">
+                <a:solidFill>
+                  <a:srgbClr val="1E2733"/>
+                </a:solidFill>
+                <a:latin typeface="Noto Sans TC"/>
+              </a:defRPr>
+            </a:pPr>
+            <a:r>
+              <a:rPr sz="1100" b="0">
                 <a:solidFill>
                   <a:srgbClr val="1E2733"/>
                 </a:solidFill>
@@ -6137,15 +6212,15 @@
               <a:spcAft>
                 <a:spcPts val="400"/>
               </a:spcAft>
-              <a:defRPr sz="1200">
-                <a:solidFill>
-                  <a:srgbClr val="1E2733"/>
-                </a:solidFill>
-                <a:latin typeface="Noto Sans TC"/>
-              </a:defRPr>
-            </a:pPr>
-            <a:r>
-              <a:rPr sz="1200" b="0">
+              <a:defRPr sz="1100">
+                <a:solidFill>
+                  <a:srgbClr val="1E2733"/>
+                </a:solidFill>
+                <a:latin typeface="Noto Sans TC"/>
+              </a:defRPr>
+            </a:pPr>
+            <a:r>
+              <a:rPr sz="1100" b="0">
                 <a:solidFill>
                   <a:srgbClr val="1E2733"/>
                 </a:solidFill>
@@ -6162,15 +6237,15 @@
               <a:spcAft>
                 <a:spcPts val="400"/>
               </a:spcAft>
-              <a:defRPr sz="1200">
-                <a:solidFill>
-                  <a:srgbClr val="1E2733"/>
-                </a:solidFill>
-                <a:latin typeface="Noto Sans TC"/>
-              </a:defRPr>
-            </a:pPr>
-            <a:r>
-              <a:rPr sz="1200" b="0">
+              <a:defRPr sz="1100">
+                <a:solidFill>
+                  <a:srgbClr val="1E2733"/>
+                </a:solidFill>
+                <a:latin typeface="Noto Sans TC"/>
+              </a:defRPr>
+            </a:pPr>
+            <a:r>
+              <a:rPr sz="1100" b="0">
                 <a:solidFill>
                   <a:srgbClr val="1E2733"/>
                 </a:solidFill>
@@ -6187,15 +6262,40 @@
               <a:spcAft>
                 <a:spcPts val="400"/>
               </a:spcAft>
-              <a:defRPr sz="1200">
-                <a:solidFill>
-                  <a:srgbClr val="1E2733"/>
-                </a:solidFill>
-                <a:latin typeface="Noto Sans TC"/>
-              </a:defRPr>
-            </a:pPr>
-            <a:r>
-              <a:rPr sz="1200" b="0">
+              <a:defRPr sz="1100">
+                <a:solidFill>
+                  <a:srgbClr val="1E2733"/>
+                </a:solidFill>
+                <a:latin typeface="Noto Sans TC"/>
+              </a:defRPr>
+            </a:pPr>
+            <a:r>
+              <a:rPr sz="1100" b="0">
+                <a:solidFill>
+                  <a:srgbClr val="1E2733"/>
+                </a:solidFill>
+                <a:latin typeface="Noto Sans TC"/>
+              </a:rPr>
+              <a:t>• Kalman injected-noise 結果依變數分化：溫度由 MA(3) 較佳，濕度由 Linear Kalman 較佳</a:t>
+            </a:r>
+          </a:p>
+          <a:p>
+            <a:pPr>
+              <a:lnSpc>
+                <a:spcPct val="114000"/>
+              </a:lnSpc>
+              <a:spcAft>
+                <a:spcPts val="400"/>
+              </a:spcAft>
+              <a:defRPr sz="1100">
+                <a:solidFill>
+                  <a:srgbClr val="1E2733"/>
+                </a:solidFill>
+                <a:latin typeface="Noto Sans TC"/>
+              </a:defRPr>
+            </a:pPr>
+            <a:r>
+              <a:rPr sz="1100" b="0">
                 <a:solidFill>
                   <a:srgbClr val="1E2733"/>
                 </a:solidFill>
@@ -6426,7 +6526,7 @@
                 </a:solidFill>
                 <a:latin typeface="Noto Sans TC"/>
               </a:rPr>
-              <a:t>• 擴大 ESP32 長期真實資料</a:t>
+              <a:t>• 擴大長期資料、dense ground truth 與 multi-zone 驗證</a:t>
             </a:r>
           </a:p>
           <a:p>
@@ -6451,7 +6551,7 @@
                 </a:solidFill>
                 <a:latin typeface="Noto Sans TC"/>
               </a:rPr>
-              <a:t>• 擴充 CO2 / PM2.5 等因子</a:t>
+              <a:t>• GRU / LSTM：SML2010 簡易同資料比較完成；兩者 lowest MAE 皆 0/12，H-RNNGATE-01 不支持</a:t>
             </a:r>
           </a:p>
           <a:p>
@@ -6476,7 +6576,7 @@
                 </a:solidFill>
                 <a:latin typeface="Noto Sans TC"/>
               </a:rPr>
-              <a:t>• 改進 multi-zone / partition 模型</a:t>
+              <a:t>• PID：相同 plant / setpoint / disturbance 的閉環控制 baseline（尚未評估）</a:t>
             </a:r>
           </a:p>
           <a:p>
@@ -6501,7 +6601,7 @@
                 </a:solidFill>
                 <a:latin typeface="Noto Sans TC"/>
               </a:rPr>
-              <a:t>• 補足 dense real-room ground truth</a:t>
+              <a:t>• 機箱 E11A/E11B 假說不支持；E11C local IDW aggregate MAE 1.223 °C，但僅勝出 21/42，H-ENC-03 不支持</a:t>
             </a:r>
           </a:p>
           <a:p>
@@ -6576,7 +6676,7 @@
                 </a:solidFill>
                 <a:latin typeface="Noto Sans TC"/>
               </a:rPr>
-              <a:t>• 定義 state/observation/noise 後比較 moving average、KF 與 EKF</a:t>
+              <a:t>• 以獨立 reference 驗證實體 sensing-node filtering，再評估 EKF/UKF</a:t>
             </a:r>
           </a:p>
         </p:txBody>
@@ -23506,8 +23606,8 @@
         </p:blipFill>
         <p:spPr>
           <a:xfrm>
-            <a:off x="1321317" y="1143000"/>
-            <a:ext cx="9564604" cy="5257800"/>
+            <a:off x="3474720" y="1143000"/>
+            <a:ext cx="5257800" cy="5257800"/>
           </a:xfrm>
           <a:prstGeom prst="rect">
             <a:avLst/>
@@ -33643,8 +33743,8 @@
         </p:blipFill>
         <p:spPr>
           <a:xfrm>
-            <a:off x="731520" y="2135777"/>
-            <a:ext cx="5486400" cy="3135085"/>
+            <a:off x="1051560" y="1280160"/>
+            <a:ext cx="4846320" cy="4846320"/>
           </a:xfrm>
           <a:prstGeom prst="rect">
             <a:avLst/>
@@ -38185,8 +38285,8 @@
         </p:blipFill>
         <p:spPr>
           <a:xfrm>
-            <a:off x="1571318" y="1024128"/>
-            <a:ext cx="9064602" cy="5230368"/>
+            <a:off x="3488436" y="1024128"/>
+            <a:ext cx="5230368" cy="5230368"/>
           </a:xfrm>
           <a:prstGeom prst="rect">
             <a:avLst/>
@@ -40664,8 +40764,8 @@
         </p:blipFill>
         <p:spPr>
           <a:xfrm>
-            <a:off x="731520" y="2116026"/>
-            <a:ext cx="5303520" cy="2900267"/>
+            <a:off x="1051560" y="1234440"/>
+            <a:ext cx="4663440" cy="4663440"/>
           </a:xfrm>
           <a:prstGeom prst="rect">
             <a:avLst/>
@@ -40699,17 +40799,17 @@
                 <a:spcPct val="112000"/>
               </a:lnSpc>
               <a:spcAft>
-                <a:spcPts val="720"/>
-              </a:spcAft>
-              <a:defRPr sz="1600">
-                <a:solidFill>
-                  <a:srgbClr val="1E2733"/>
-                </a:solidFill>
-                <a:latin typeface="Noto Sans TC"/>
-              </a:defRPr>
-            </a:pPr>
-            <a:r>
-              <a:rPr sz="1600" b="0">
+                <a:spcPts val="630"/>
+              </a:spcAft>
+              <a:defRPr sz="1400">
+                <a:solidFill>
+                  <a:srgbClr val="1E2733"/>
+                </a:solidFill>
+                <a:latin typeface="Noto Sans TC"/>
+              </a:defRPr>
+            </a:pPr>
+            <a:r>
+              <a:rPr sz="1400" b="0">
                 <a:solidFill>
                   <a:srgbClr val="1E2733"/>
                 </a:solidFill>
@@ -40724,17 +40824,17 @@
                 <a:spcPct val="112000"/>
               </a:lnSpc>
               <a:spcAft>
-                <a:spcPts val="720"/>
-              </a:spcAft>
-              <a:defRPr sz="1600">
-                <a:solidFill>
-                  <a:srgbClr val="1E2733"/>
-                </a:solidFill>
-                <a:latin typeface="Noto Sans TC"/>
-              </a:defRPr>
-            </a:pPr>
-            <a:r>
-              <a:rPr sz="1600" b="0">
+                <a:spcPts val="630"/>
+              </a:spcAft>
+              <a:defRPr sz="1400">
+                <a:solidFill>
+                  <a:srgbClr val="1E2733"/>
+                </a:solidFill>
+                <a:latin typeface="Noto Sans TC"/>
+              </a:defRPr>
+            </a:pPr>
+            <a:r>
+              <a:rPr sz="1400" b="0">
                 <a:solidFill>
                   <a:srgbClr val="1E2733"/>
                 </a:solidFill>
@@ -40749,17 +40849,17 @@
                 <a:spcPct val="112000"/>
               </a:lnSpc>
               <a:spcAft>
-                <a:spcPts val="720"/>
-              </a:spcAft>
-              <a:defRPr sz="1600">
-                <a:solidFill>
-                  <a:srgbClr val="1E2733"/>
-                </a:solidFill>
-                <a:latin typeface="Noto Sans TC"/>
-              </a:defRPr>
-            </a:pPr>
-            <a:r>
-              <a:rPr sz="1600" b="0">
+                <a:spcPts val="630"/>
+              </a:spcAft>
+              <a:defRPr sz="1400">
+                <a:solidFill>
+                  <a:srgbClr val="1E2733"/>
+                </a:solidFill>
+                <a:latin typeface="Noto Sans TC"/>
+              </a:defRPr>
+            </a:pPr>
+            <a:r>
+              <a:rPr sz="1400" b="0">
                 <a:solidFill>
                   <a:srgbClr val="1E2733"/>
                 </a:solidFill>
@@ -40774,17 +40874,17 @@
                 <a:spcPct val="112000"/>
               </a:lnSpc>
               <a:spcAft>
-                <a:spcPts val="720"/>
-              </a:spcAft>
-              <a:defRPr sz="1600">
-                <a:solidFill>
-                  <a:srgbClr val="1E2733"/>
-                </a:solidFill>
-                <a:latin typeface="Noto Sans TC"/>
-              </a:defRPr>
-            </a:pPr>
-            <a:r>
-              <a:rPr sz="1600" b="0">
+                <a:spcPts val="630"/>
+              </a:spcAft>
+              <a:defRPr sz="1400">
+                <a:solidFill>
+                  <a:srgbClr val="1E2733"/>
+                </a:solidFill>
+                <a:latin typeface="Noto Sans TC"/>
+              </a:defRPr>
+            </a:pPr>
+            <a:r>
+              <a:rPr sz="1400" b="0">
                 <a:solidFill>
                   <a:srgbClr val="1E2733"/>
                 </a:solidFill>
@@ -40799,17 +40899,17 @@
                 <a:spcPct val="112000"/>
               </a:lnSpc>
               <a:spcAft>
-                <a:spcPts val="720"/>
-              </a:spcAft>
-              <a:defRPr sz="1600">
-                <a:solidFill>
-                  <a:srgbClr val="1E2733"/>
-                </a:solidFill>
-                <a:latin typeface="Noto Sans TC"/>
-              </a:defRPr>
-            </a:pPr>
-            <a:r>
-              <a:rPr sz="1600" b="0">
+                <a:spcPts val="630"/>
+              </a:spcAft>
+              <a:defRPr sz="1400">
+                <a:solidFill>
+                  <a:srgbClr val="1E2733"/>
+                </a:solidFill>
+                <a:latin typeface="Noto Sans TC"/>
+              </a:defRPr>
+            </a:pPr>
+            <a:r>
+              <a:rPr sz="1400" b="0">
                 <a:solidFill>
                   <a:srgbClr val="1E2733"/>
                 </a:solidFill>
@@ -40824,17 +40924,17 @@
                 <a:spcPct val="112000"/>
               </a:lnSpc>
               <a:spcAft>
-                <a:spcPts val="720"/>
-              </a:spcAft>
-              <a:defRPr sz="1600">
-                <a:solidFill>
-                  <a:srgbClr val="1E2733"/>
-                </a:solidFill>
-                <a:latin typeface="Noto Sans TC"/>
-              </a:defRPr>
-            </a:pPr>
-            <a:r>
-              <a:rPr sz="1600" b="0">
+                <a:spcPts val="630"/>
+              </a:spcAft>
+              <a:defRPr sz="1400">
+                <a:solidFill>
+                  <a:srgbClr val="1E2733"/>
+                </a:solidFill>
+                <a:latin typeface="Noto Sans TC"/>
+              </a:defRPr>
+            </a:pPr>
+            <a:r>
+              <a:rPr sz="1400" b="0">
                 <a:solidFill>
                   <a:srgbClr val="1E2733"/>
                 </a:solidFill>
@@ -40849,23 +40949,23 @@
                 <a:spcPct val="112000"/>
               </a:lnSpc>
               <a:spcAft>
-                <a:spcPts val="720"/>
-              </a:spcAft>
-              <a:defRPr sz="1600">
-                <a:solidFill>
-                  <a:srgbClr val="1E2733"/>
-                </a:solidFill>
-                <a:latin typeface="Noto Sans TC"/>
-              </a:defRPr>
-            </a:pPr>
-            <a:r>
-              <a:rPr sz="1600" b="0">
-                <a:solidFill>
-                  <a:srgbClr val="1E2733"/>
-                </a:solidFill>
-                <a:latin typeface="Noto Sans TC"/>
-              </a:rPr>
-              <a:t>• E9 public benchmark；demo 不是量化實驗</a:t>
+                <a:spcPts val="630"/>
+              </a:spcAft>
+              <a:defRPr sz="1400">
+                <a:solidFill>
+                  <a:srgbClr val="1E2733"/>
+                </a:solidFill>
+                <a:latin typeface="Noto Sans TC"/>
+              </a:defRPr>
+            </a:pPr>
+            <a:r>
+              <a:rPr sz="1400" b="0">
+                <a:solidFill>
+                  <a:srgbClr val="1E2733"/>
+                </a:solidFill>
+                <a:latin typeface="Noto Sans TC"/>
+              </a:rPr>
+              <a:t>• E9 public benchmark；E10 controlled filtering；E11A BMC temporal transfer；demo 不是量化實驗</a:t>
             </a:r>
           </a:p>
         </p:txBody>

</xml_diff>